<commit_message>
Remove AI formatting symbols and Ansible references
</commit_message>
<xml_diff>
--- a/Presentasi_SysAdmin_McKinsey.pptx
+++ b/Presentasi_SysAdmin_McKinsey.pptx
@@ -4961,7 +4961,7 @@
               </a:defRPr>
             </a:pPr>
             <a:r>
-              <a:t>Ansible auto-create directory</a:t>
+              <a:t>Buat directory secara manual</a:t>
             </a:r>
           </a:p>
         </p:txBody>
@@ -6015,7 +6015,7 @@
               </a:defRPr>
             </a:pPr>
             <a:r>
-              <a:t>Seluruh konfigurasi diotomasi menggunakan Ansible - fully reproducible</a:t>
+              <a:t>Seluruh konfigurasi dilakukan secara manual - sepenuhnya terdokumentasi</a:t>
             </a:r>
           </a:p>
         </p:txBody>
@@ -7689,7 +7689,7 @@
               </a:defRPr>
             </a:pPr>
             <a:r>
-              <a:t>Solusi: Ansible Infrastructure-as-Code untuk deployment otomatis dan reproducible</a:t>
+              <a:t>Solusi: Konfigurasi manual terstruktur untuk administrasi yang presisi</a:t>
             </a:r>
           </a:p>
         </p:txBody>
@@ -7981,7 +7981,7 @@
               </a:defRPr>
             </a:pPr>
             <a:r>
-              <a:t>Windows 10/11 + WSL (Ansible)</a:t>
+              <a:t>Windows 10/11 + SSH Client</a:t>
             </a:r>
           </a:p>
         </p:txBody>

</xml_diff>